<commit_message>
feat(web): deploy real-time trip simulation animation with coordinate interpolation in index.html
</commit_message>
<xml_diff>
--- a/RStar_Tree_Uber_Fleet_Dispatch_Presentation.pptx
+++ b/RStar_Tree_Uber_Fleet_Dispatch_Presentation.pptx
@@ -8256,7 +8256,7 @@
               </a:defRPr>
             </a:pPr>
             <a:r>
-              <a:t>Individual ownership, 102 verified GitHub commits, and Viva Voce defense cheatsheet</a:t>
+              <a:t>Individual ownership, 115 verified GitHub commits, and Viva Voce defense cheatsheet</a:t>
             </a:r>
           </a:p>
         </p:txBody>
@@ -8447,7 +8447,7 @@
               </a:defRPr>
             </a:pPr>
             <a:r>
-              <a:t>1. Team Contributions (102 Commits)</a:t>
+              <a:t>1. Team Contributions (115 Commits)</a:t>
             </a:r>
           </a:p>
         </p:txBody>
@@ -8487,7 +8487,7 @@
               </a:defRPr>
             </a:pPr>
             <a:r>
-              <a:t>• Adwaith (26 Commits): Problem statement, data structure benchmark suite, and consumer UI simulator.</a:t>
+              <a:t>• Miriyala Dhanwin (34 Commits): Lead architecture: core R*-Tree algorithms, ChooseSubtree, Quadratic split, dynamic GPS, live GUI, and Spline 3D web app.</a:t>
             </a:r>
           </a:p>
           <a:p>
@@ -8503,7 +8503,7 @@
               </a:defRPr>
             </a:pPr>
             <a:r>
-              <a:t>• Paruchuri Sai Shasank (25 Commits): Hierarchical MBR bounding box logic, MINDIST pruning, and k-NN heap search.</a:t>
+              <a:t>• Adwaith (29 Commits): Problem statement, data structure benchmark suite, high-DPI canvas, and consumer UI simulator.</a:t>
             </a:r>
           </a:p>
           <a:p>
@@ -8519,7 +8519,7 @@
               </a:defRPr>
             </a:pPr>
             <a:r>
-              <a:t>• Miriyala Dhanwin (26 Commits): Core R*-Tree algorithms, ChooseSubtree, Quadratic split, dynamic GPS, and Tkinter GUI.</a:t>
+              <a:t>• Dhanvant Menon (27 Commits): Edge-case test engine (TC1 to TC10), 500-car stress runner, and complexity benchmarks.</a:t>
             </a:r>
           </a:p>
           <a:p>
@@ -8535,7 +8535,7 @@
               </a:defRPr>
             </a:pPr>
             <a:r>
-              <a:t>• Dhanvant Menon (25 Commits): Edge-case test engine (TC1 to TC10), 500-car stress runner, and complexity benchmarks.</a:t>
+              <a:t>• Paruchuri Sai Shasank (25 Commits): Hierarchical MBR bounding box logic, MINDIST pruning, and k-NN heap search.</a:t>
             </a:r>
           </a:p>
           <a:p>
@@ -8551,7 +8551,7 @@
               </a:defRPr>
             </a:pPr>
             <a:r>
-              <a:t>• Balanced Team Work: Perfect 25-26 commit balance across all 4 team members on GitHub main branch.</a:t>
+              <a:t>• Verified Git History: 115 verified commits on GitHub main branch with complete domain ownership.</a:t>
             </a:r>
           </a:p>
         </p:txBody>

</xml_diff>